<commit_message>
All 20 CONUS variants: level-calibrated localized max beats native in 19
Full per-variant SDIMAX level sweep through the engine. Calibrated localized maximum
<= native RMSE in 19/20 variants (UT exception); optimal level 0.6-2.0, median 1.2 (no
uniform drop-in). Big gains where native level most off (NC 75->54, ACD 53->37, NE 35->31).
Updates report, deck, and Word doc with the all-variant table + figure; adds
allvar_calibration.csv and figure.
</commit_message>
<xml_diff>
--- a/calibration/sdimax/FVS_team_briefing_CONUS_maxSDI.pptx
+++ b/calibration/sdimax/FVS_team_briefing_CONUS_maxSDI.pptx
@@ -19,9 +19,10 @@
     <p:sldId id="267" r:id="rId13"/>
     <p:sldId id="268" r:id="rId14"/>
     <p:sldId id="269" r:id="rId15"/>
+    <p:sldId id="270" r:id="rId16"/>
   </p:sldIdLst>
   <p:notesMasterIdLst>
-    <p:notesMasterId r:id="rId16"/>
+    <p:notesMasterId r:id="rId17"/>
   </p:notesMasterIdLst>
   <p:sldSz cx="12188952" cy="6858000"/>
   <p:notesSz cx="6858000" cy="12188952"/>
@@ -979,6 +980,94 @@
             <a:fld id="{F7021451-1387-4CA6-816F-3879F97B5CBC}" type="slidenum">
               <a:rPr lang="en-US"/>
               <a:t>14</a:t>
+            </a:fld>
+            <a:endParaRPr lang="en-US"/>
+          </a:p>
+        </p:txBody>
+      </p:sp>
+    </p:spTree>
+    <p:extLst>
+      <p:ext uri="{BB962C8B-B14F-4D97-AF65-F5344CB8AC3E}">
+        <p14:creationId xmlns:p14="http://schemas.microsoft.com/office/powerpoint/2010/main" val="1024086991"/>
+      </p:ext>
+    </p:extLst>
+  </p:cSld>
+  <p:clrMapOvr>
+    <a:masterClrMapping/>
+  </p:clrMapOvr>
+</p:notes>
+</file>
+
+<file path=ppt/notesSlides/notesSlide15.xml><?xml version="1.0" encoding="utf-8"?>
+<p:notes xmlns:a="http://schemas.openxmlformats.org/drawingml/2006/main" xmlns:r="http://schemas.openxmlformats.org/officeDocument/2006/relationships" xmlns:p="http://schemas.openxmlformats.org/presentationml/2006/main">
+  <p:cSld>
+    <p:spTree>
+      <p:nvGrpSpPr>
+        <p:cNvPr id="1" name=""/>
+        <p:cNvGrpSpPr/>
+        <p:nvPr/>
+      </p:nvGrpSpPr>
+      <p:grpSpPr>
+        <a:xfrm>
+          <a:off x="0" y="0"/>
+          <a:ext cx="0" cy="0"/>
+          <a:chOff x="0" y="0"/>
+          <a:chExt cx="0" cy="0"/>
+        </a:xfrm>
+      </p:grpSpPr>
+      <p:sp>
+        <p:nvSpPr>
+          <p:cNvPr id="2" name="Slide Image Placeholder 1"/>
+          <p:cNvSpPr>
+            <a:spLocks noGrp="1" noRot="1" noChangeAspect="1"/>
+          </p:cNvSpPr>
+          <p:nvPr>
+            <p:ph type="sldImg"/>
+          </p:nvPr>
+        </p:nvSpPr>
+        <p:spPr/>
+      </p:sp>
+      <p:sp>
+        <p:nvSpPr>
+          <p:cNvPr id="3" name="Notes Placeholder 2"/>
+          <p:cNvSpPr>
+            <a:spLocks noGrp="1"/>
+          </p:cNvSpPr>
+          <p:nvPr>
+            <p:ph type="body" idx="1"/>
+          </p:nvPr>
+        </p:nvSpPr>
+        <p:spPr/>
+        <p:txBody>
+          <a:bodyPr/>
+          <a:lstStyle/>
+          <a:p>
+            <a:r>
+              <a:rPr lang="en-US" dirty="0"/>
+              <a:t/>
+            </a:r>
+            <a:endParaRPr lang="en-US" dirty="0"/>
+          </a:p>
+        </p:txBody>
+      </p:sp>
+      <p:sp>
+        <p:nvSpPr>
+          <p:cNvPr id="4" name="Slide Number Placeholder 3"/>
+          <p:cNvSpPr>
+            <a:spLocks noGrp="1"/>
+          </p:cNvSpPr>
+          <p:nvPr>
+            <p:ph type="sldNum" sz="quarter" idx="10"/>
+          </p:nvPr>
+        </p:nvSpPr>
+        <p:spPr/>
+        <p:txBody>
+          <a:bodyPr/>
+          <a:lstStyle/>
+          <a:p>
+            <a:fld id="{F7021451-1387-4CA6-816F-3879F97B5CBC}" type="slidenum">
+              <a:rPr lang="en-US"/>
+              <a:t>15</a:t>
             </a:fld>
             <a:endParaRPr lang="en-US"/>
           </a:p>
@@ -2897,22 +2986,46 @@
                 <a:ea typeface="Aptos Display" pitchFamily="34" charset="-122"/>
                 <a:cs typeface="Aptos Display" pitchFamily="34" charset="-120"/>
               </a:rPr>
-              <a:t>Where the density limit matters most (7.25 million plots)</a:t>
+              <a:t>Across all 20 CONUS variants: calibrated localized beats native in 19</a:t>
             </a:r>
             <a:endParaRPr lang="en-US" sz="3000" dirty="0"/>
           </a:p>
         </p:txBody>
       </p:sp>
-      <p:sp>
-        <p:nvSpPr>
-          <p:cNvPr id="3" name="Text 1"/>
-          <p:cNvSpPr/>
-          <p:nvPr/>
-        </p:nvSpPr>
-        <p:spPr>
-          <a:xfrm>
-            <a:off x="548640" y="1143000"/>
-            <a:ext cx="10972800" cy="365760"/>
+      <p:pic>
+        <p:nvPicPr>
+          <p:cNvPr id="3" name="Image 0" descr="allvar_level_calibration.png">    </p:cNvPr>
+          <p:cNvPicPr>
+            <a:picLocks noChangeAspect="1"/>
+          </p:cNvPicPr>
+          <p:nvPr/>
+        </p:nvPicPr>
+        <p:blipFill>
+          <a:blip r:embed="rId1"/>
+          <a:stretch>
+            <a:fillRect/>
+          </a:stretch>
+        </p:blipFill>
+        <p:spPr>
+          <a:xfrm>
+            <a:off x="502920" y="1325880"/>
+            <a:ext cx="11155680" cy="4206240"/>
+          </a:xfrm>
+          <a:prstGeom prst="rect">
+            <a:avLst/>
+          </a:prstGeom>
+        </p:spPr>
+      </p:pic>
+      <p:sp>
+        <p:nvSpPr>
+          <p:cNvPr id="4" name="Text 1"/>
+          <p:cNvSpPr/>
+          <p:nvPr/>
+        </p:nvSpPr>
+        <p:spPr>
+          <a:xfrm>
+            <a:off x="548640" y="5623560"/>
+            <a:ext cx="11064240" cy="365760"/>
           </a:xfrm>
           <a:prstGeom prst="rect">
             <a:avLst/>
@@ -2928,7 +3041,7 @@
               <a:buNone/>
             </a:pPr>
             <a:r>
-              <a:rPr lang="en-US" sz="1500" dirty="0">
+              <a:rPr lang="en-US" sz="1300" i="1" dirty="0">
                 <a:solidFill>
                   <a:srgbClr val="666666"/>
                 </a:solidFill>
@@ -2936,212 +3049,15 @@
                 <a:ea typeface="Aptos" pitchFamily="34" charset="-122"/>
                 <a:cs typeface="Aptos" pitchFamily="34" charset="-120"/>
               </a:rPr>
-              <a:t>Strength of the self-thinning signal varies about four-fold by region</a:t>
-            </a:r>
-            <a:endParaRPr lang="en-US" sz="1500" dirty="0"/>
-          </a:p>
-        </p:txBody>
-      </p:sp>
-      <p:sp>
-        <p:nvSpPr>
-          <p:cNvPr id="4" name="Text 2"/>
-          <p:cNvSpPr/>
-          <p:nvPr/>
-        </p:nvSpPr>
-        <p:spPr>
-          <a:xfrm>
-            <a:off x="822960" y="2011680"/>
-            <a:ext cx="5029200" cy="2286000"/>
-          </a:xfrm>
-          <a:prstGeom prst="rect">
-            <a:avLst/>
-          </a:prstGeom>
-          <a:solidFill>
-            <a:srgbClr val="FBF1EB"/>
-          </a:solidFill>
-          <a:ln/>
-        </p:spPr>
-        <p:txBody>
-          <a:bodyPr wrap="square" rtlCol="0" anchor="t"/>
-          <a:lstStyle/>
-          <a:p>
-            <a:pPr algn="l" indent="0" marL="0">
-              <a:buNone/>
-            </a:pPr>
-            <a:r>
-              <a:rPr lang="en-US" sz="1800" b="1" dirty="0">
-                <a:solidFill>
-                  <a:srgbClr val="B0682F"/>
-                </a:solidFill>
-                <a:latin typeface="Aptos" pitchFamily="34" charset="0"/>
-                <a:ea typeface="Aptos" pitchFamily="34" charset="-122"/>
-                <a:cs typeface="Aptos" pitchFamily="34" charset="-120"/>
-              </a:rPr>
-              <a:t>Weakest: dry interior West
-</a:t>
-            </a:r>
-            <a:pPr algn="l" indent="0" marL="0">
-              <a:buNone/>
-            </a:pPr>
-            <a:r>
-              <a:rPr lang="en-US" sz="1500" dirty="0">
-                <a:solidFill>
-                  <a:srgbClr val="333333"/>
-                </a:solidFill>
-                <a:latin typeface="Aptos" pitchFamily="34" charset="0"/>
-                <a:ea typeface="Aptos" pitchFamily="34" charset="-122"/>
-                <a:cs typeface="Aptos" pitchFamily="34" charset="-120"/>
-              </a:rPr>
-              <a:t>Utah 0.04, Central Idaho 0.05, Central Rockies 0.06</a:t>
-            </a:r>
-            <a:endParaRPr lang="en-US" sz="1800" dirty="0"/>
-          </a:p>
-          <a:p>
-            <a:pPr algn="l" indent="0" marL="0">
-              <a:buNone/>
-            </a:pPr>
-            <a:endParaRPr lang="en-US" sz="1800" dirty="0"/>
-          </a:p>
-          <a:p>
-            <a:pPr algn="l" indent="0" marL="0">
-              <a:buNone/>
-            </a:pPr>
-            <a:r>
-              <a:rPr lang="en-US" sz="1500" dirty="0">
-                <a:solidFill>
-                  <a:srgbClr val="333333"/>
-                </a:solidFill>
-                <a:latin typeface="Aptos" pitchFamily="34" charset="0"/>
-                <a:ea typeface="Aptos" pitchFamily="34" charset="-122"/>
-                <a:cs typeface="Aptos" pitchFamily="34" charset="-120"/>
-              </a:rPr>
-              <a:t>drought and disturbance dominate mortality</a:t>
-            </a:r>
-            <a:endParaRPr lang="en-US" sz="1800" dirty="0"/>
-          </a:p>
-        </p:txBody>
-      </p:sp>
-      <p:sp>
-        <p:nvSpPr>
-          <p:cNvPr id="5" name="Text 3"/>
-          <p:cNvSpPr/>
-          <p:nvPr/>
-        </p:nvSpPr>
-        <p:spPr>
-          <a:xfrm>
-            <a:off x="6309360" y="2011680"/>
-            <a:ext cx="5029200" cy="2286000"/>
-          </a:xfrm>
-          <a:prstGeom prst="rect">
-            <a:avLst/>
-          </a:prstGeom>
-          <a:solidFill>
-            <a:srgbClr val="EDF3EE"/>
-          </a:solidFill>
-          <a:ln/>
-        </p:spPr>
-        <p:txBody>
-          <a:bodyPr wrap="square" rtlCol="0" anchor="t"/>
-          <a:lstStyle/>
-          <a:p>
-            <a:pPr algn="l" indent="0" marL="0">
-              <a:buNone/>
-            </a:pPr>
-            <a:r>
-              <a:rPr lang="en-US" sz="1800" b="1" dirty="0">
-                <a:solidFill>
-                  <a:srgbClr val="1A3D28"/>
-                </a:solidFill>
-                <a:latin typeface="Aptos" pitchFamily="34" charset="0"/>
-                <a:ea typeface="Aptos" pitchFamily="34" charset="-122"/>
-                <a:cs typeface="Aptos" pitchFamily="34" charset="-120"/>
-              </a:rPr>
-              <a:t>Strongest: moist East, South, PNW
-</a:t>
-            </a:r>
-            <a:pPr algn="l" indent="0" marL="0">
-              <a:buNone/>
-            </a:pPr>
-            <a:r>
-              <a:rPr lang="en-US" sz="1500" dirty="0">
-                <a:solidFill>
-                  <a:srgbClr val="333333"/>
-                </a:solidFill>
-                <a:latin typeface="Aptos" pitchFamily="34" charset="0"/>
-                <a:ea typeface="Aptos" pitchFamily="34" charset="-122"/>
-                <a:cs typeface="Aptos" pitchFamily="34" charset="-120"/>
-              </a:rPr>
-              <a:t>Southern 0.14, Blue Mountains 0.12, Pacific NW 0.10, Northeast 0.10</a:t>
-            </a:r>
-            <a:endParaRPr lang="en-US" sz="1800" dirty="0"/>
-          </a:p>
-          <a:p>
-            <a:pPr algn="l" indent="0" marL="0">
-              <a:buNone/>
-            </a:pPr>
-            <a:endParaRPr lang="en-US" sz="1800" dirty="0"/>
-          </a:p>
-          <a:p>
-            <a:pPr algn="l" indent="0" marL="0">
-              <a:buNone/>
-            </a:pPr>
-            <a:r>
-              <a:rPr lang="en-US" sz="1500" dirty="0">
-                <a:solidFill>
-                  <a:srgbClr val="333333"/>
-                </a:solidFill>
-                <a:latin typeface="Aptos" pitchFamily="34" charset="0"/>
-                <a:ea typeface="Aptos" pitchFamily="34" charset="-122"/>
-                <a:cs typeface="Aptos" pitchFamily="34" charset="-120"/>
-              </a:rPr>
-              <a:t>self-thinning is the primary control</a:t>
-            </a:r>
-            <a:endParaRPr lang="en-US" sz="1800" dirty="0"/>
-          </a:p>
-        </p:txBody>
-      </p:sp>
-      <p:sp>
-        <p:nvSpPr>
-          <p:cNvPr id="6" name="Text 4"/>
-          <p:cNvSpPr/>
-          <p:nvPr/>
-        </p:nvSpPr>
-        <p:spPr>
-          <a:xfrm>
-            <a:off x="822960" y="4617720"/>
-            <a:ext cx="10515600" cy="822960"/>
-          </a:xfrm>
-          <a:prstGeom prst="rect">
-            <a:avLst/>
-          </a:prstGeom>
-          <a:noFill/>
-          <a:ln/>
-        </p:spPr>
-        <p:txBody>
-          <a:bodyPr wrap="square" rtlCol="0" anchor="ctr"/>
-          <a:lstStyle/>
-          <a:p>
-            <a:pPr indent="0" marL="0">
-              <a:buNone/>
-            </a:pPr>
-            <a:r>
-              <a:rPr lang="en-US" sz="1600" i="1" dirty="0">
-                <a:solidFill>
-                  <a:srgbClr val="1A3D28"/>
-                </a:solidFill>
-                <a:latin typeface="Aptos" pitchFamily="34" charset="0"/>
-                <a:ea typeface="Aptos" pitchFamily="34" charset="-122"/>
-                <a:cs typeface="Aptos" pitchFamily="34" charset="-120"/>
-              </a:rPr>
-              <a:t>Same axis as the projection result: localizing the maximum pays off most where self-thinning governs stand dynamics</a:t>
-            </a:r>
-            <a:endParaRPr lang="en-US" sz="1600" dirty="0"/>
-          </a:p>
-        </p:txBody>
-      </p:sp>
-      <p:sp>
-        <p:nvSpPr>
-          <p:cNvPr id="7" name="Shape 5"/>
+              <a:t>Optimal level spans 0.6 to 2.0 (median 1.2): no single global level works, each variant needs its own</a:t>
+            </a:r>
+            <a:endParaRPr lang="en-US" sz="1300" dirty="0"/>
+          </a:p>
+        </p:txBody>
+      </p:sp>
+      <p:sp>
+        <p:nvSpPr>
+          <p:cNvPr id="5" name="Shape 2"/>
           <p:cNvSpPr/>
           <p:nvPr/>
         </p:nvSpPr>
@@ -3161,7 +3077,7 @@
       </p:sp>
       <p:sp>
         <p:nvSpPr>
-          <p:cNvPr id="8" name="Text 6"/>
+          <p:cNvPr id="6" name="Text 3"/>
           <p:cNvSpPr/>
           <p:nvPr/>
         </p:nvSpPr>
@@ -3192,7 +3108,7 @@
                 <a:ea typeface="Aptos" pitchFamily="34" charset="-122"/>
                 <a:cs typeface="Aptos" pitchFamily="34" charset="-120"/>
               </a:rPr>
-              <a:t>Get the maximum right first in the East, South, and moist West</a:t>
+              <a:t>A level-calibrated localized maximum matches or beats native in 19 of 20 variants</a:t>
             </a:r>
             <a:endParaRPr lang="en-US" sz="1800" dirty="0"/>
           </a:p>
@@ -3263,7 +3179,7 @@
                 <a:ea typeface="Aptos Display" pitchFamily="34" charset="-122"/>
                 <a:cs typeface="Aptos Display" pitchFamily="34" charset="-120"/>
               </a:rPr>
-              <a:t>Recommendations for the FVS team</a:t>
+              <a:t>Where the density limit matters most (7.25 million plots)</a:t>
             </a:r>
             <a:endParaRPr lang="en-US" sz="3000" dirty="0"/>
           </a:p>
@@ -3271,16 +3187,252 @@
       </p:sp>
       <p:sp>
         <p:nvSpPr>
-          <p:cNvPr id="3" name="Shape 1"/>
-          <p:cNvSpPr/>
-          <p:nvPr/>
-        </p:nvSpPr>
-        <p:spPr>
-          <a:xfrm>
-            <a:off x="640080" y="1600200"/>
-            <a:ext cx="502920" cy="502920"/>
-          </a:xfrm>
-          <a:prstGeom prst="ellipse">
+          <p:cNvPr id="3" name="Text 1"/>
+          <p:cNvSpPr/>
+          <p:nvPr/>
+        </p:nvSpPr>
+        <p:spPr>
+          <a:xfrm>
+            <a:off x="548640" y="1143000"/>
+            <a:ext cx="10972800" cy="365760"/>
+          </a:xfrm>
+          <a:prstGeom prst="rect">
+            <a:avLst/>
+          </a:prstGeom>
+          <a:noFill/>
+          <a:ln/>
+        </p:spPr>
+        <p:txBody>
+          <a:bodyPr wrap="square" rtlCol="0" anchor="ctr"/>
+          <a:lstStyle/>
+          <a:p>
+            <a:pPr indent="0" marL="0">
+              <a:buNone/>
+            </a:pPr>
+            <a:r>
+              <a:rPr lang="en-US" sz="1500" dirty="0">
+                <a:solidFill>
+                  <a:srgbClr val="666666"/>
+                </a:solidFill>
+                <a:latin typeface="Aptos" pitchFamily="34" charset="0"/>
+                <a:ea typeface="Aptos" pitchFamily="34" charset="-122"/>
+                <a:cs typeface="Aptos" pitchFamily="34" charset="-120"/>
+              </a:rPr>
+              <a:t>Strength of the self-thinning signal varies about four-fold by region</a:t>
+            </a:r>
+            <a:endParaRPr lang="en-US" sz="1500" dirty="0"/>
+          </a:p>
+        </p:txBody>
+      </p:sp>
+      <p:sp>
+        <p:nvSpPr>
+          <p:cNvPr id="4" name="Text 2"/>
+          <p:cNvSpPr/>
+          <p:nvPr/>
+        </p:nvSpPr>
+        <p:spPr>
+          <a:xfrm>
+            <a:off x="822960" y="2011680"/>
+            <a:ext cx="5029200" cy="2286000"/>
+          </a:xfrm>
+          <a:prstGeom prst="rect">
+            <a:avLst/>
+          </a:prstGeom>
+          <a:solidFill>
+            <a:srgbClr val="FBF1EB"/>
+          </a:solidFill>
+          <a:ln/>
+        </p:spPr>
+        <p:txBody>
+          <a:bodyPr wrap="square" rtlCol="0" anchor="t"/>
+          <a:lstStyle/>
+          <a:p>
+            <a:pPr algn="l" indent="0" marL="0">
+              <a:buNone/>
+            </a:pPr>
+            <a:r>
+              <a:rPr lang="en-US" sz="1800" b="1" dirty="0">
+                <a:solidFill>
+                  <a:srgbClr val="B0682F"/>
+                </a:solidFill>
+                <a:latin typeface="Aptos" pitchFamily="34" charset="0"/>
+                <a:ea typeface="Aptos" pitchFamily="34" charset="-122"/>
+                <a:cs typeface="Aptos" pitchFamily="34" charset="-120"/>
+              </a:rPr>
+              <a:t>Weakest: dry interior West
+</a:t>
+            </a:r>
+            <a:pPr algn="l" indent="0" marL="0">
+              <a:buNone/>
+            </a:pPr>
+            <a:r>
+              <a:rPr lang="en-US" sz="1500" dirty="0">
+                <a:solidFill>
+                  <a:srgbClr val="333333"/>
+                </a:solidFill>
+                <a:latin typeface="Aptos" pitchFamily="34" charset="0"/>
+                <a:ea typeface="Aptos" pitchFamily="34" charset="-122"/>
+                <a:cs typeface="Aptos" pitchFamily="34" charset="-120"/>
+              </a:rPr>
+              <a:t>Utah 0.04, Central Idaho 0.05, Central Rockies 0.06</a:t>
+            </a:r>
+            <a:endParaRPr lang="en-US" sz="1800" dirty="0"/>
+          </a:p>
+          <a:p>
+            <a:pPr algn="l" indent="0" marL="0">
+              <a:buNone/>
+            </a:pPr>
+            <a:endParaRPr lang="en-US" sz="1800" dirty="0"/>
+          </a:p>
+          <a:p>
+            <a:pPr algn="l" indent="0" marL="0">
+              <a:buNone/>
+            </a:pPr>
+            <a:r>
+              <a:rPr lang="en-US" sz="1500" dirty="0">
+                <a:solidFill>
+                  <a:srgbClr val="333333"/>
+                </a:solidFill>
+                <a:latin typeface="Aptos" pitchFamily="34" charset="0"/>
+                <a:ea typeface="Aptos" pitchFamily="34" charset="-122"/>
+                <a:cs typeface="Aptos" pitchFamily="34" charset="-120"/>
+              </a:rPr>
+              <a:t>drought and disturbance dominate mortality</a:t>
+            </a:r>
+            <a:endParaRPr lang="en-US" sz="1800" dirty="0"/>
+          </a:p>
+        </p:txBody>
+      </p:sp>
+      <p:sp>
+        <p:nvSpPr>
+          <p:cNvPr id="5" name="Text 3"/>
+          <p:cNvSpPr/>
+          <p:nvPr/>
+        </p:nvSpPr>
+        <p:spPr>
+          <a:xfrm>
+            <a:off x="6309360" y="2011680"/>
+            <a:ext cx="5029200" cy="2286000"/>
+          </a:xfrm>
+          <a:prstGeom prst="rect">
+            <a:avLst/>
+          </a:prstGeom>
+          <a:solidFill>
+            <a:srgbClr val="EDF3EE"/>
+          </a:solidFill>
+          <a:ln/>
+        </p:spPr>
+        <p:txBody>
+          <a:bodyPr wrap="square" rtlCol="0" anchor="t"/>
+          <a:lstStyle/>
+          <a:p>
+            <a:pPr algn="l" indent="0" marL="0">
+              <a:buNone/>
+            </a:pPr>
+            <a:r>
+              <a:rPr lang="en-US" sz="1800" b="1" dirty="0">
+                <a:solidFill>
+                  <a:srgbClr val="1A3D28"/>
+                </a:solidFill>
+                <a:latin typeface="Aptos" pitchFamily="34" charset="0"/>
+                <a:ea typeface="Aptos" pitchFamily="34" charset="-122"/>
+                <a:cs typeface="Aptos" pitchFamily="34" charset="-120"/>
+              </a:rPr>
+              <a:t>Strongest: moist East, South, PNW
+</a:t>
+            </a:r>
+            <a:pPr algn="l" indent="0" marL="0">
+              <a:buNone/>
+            </a:pPr>
+            <a:r>
+              <a:rPr lang="en-US" sz="1500" dirty="0">
+                <a:solidFill>
+                  <a:srgbClr val="333333"/>
+                </a:solidFill>
+                <a:latin typeface="Aptos" pitchFamily="34" charset="0"/>
+                <a:ea typeface="Aptos" pitchFamily="34" charset="-122"/>
+                <a:cs typeface="Aptos" pitchFamily="34" charset="-120"/>
+              </a:rPr>
+              <a:t>Southern 0.14, Blue Mountains 0.12, Pacific NW 0.10, Northeast 0.10</a:t>
+            </a:r>
+            <a:endParaRPr lang="en-US" sz="1800" dirty="0"/>
+          </a:p>
+          <a:p>
+            <a:pPr algn="l" indent="0" marL="0">
+              <a:buNone/>
+            </a:pPr>
+            <a:endParaRPr lang="en-US" sz="1800" dirty="0"/>
+          </a:p>
+          <a:p>
+            <a:pPr algn="l" indent="0" marL="0">
+              <a:buNone/>
+            </a:pPr>
+            <a:r>
+              <a:rPr lang="en-US" sz="1500" dirty="0">
+                <a:solidFill>
+                  <a:srgbClr val="333333"/>
+                </a:solidFill>
+                <a:latin typeface="Aptos" pitchFamily="34" charset="0"/>
+                <a:ea typeface="Aptos" pitchFamily="34" charset="-122"/>
+                <a:cs typeface="Aptos" pitchFamily="34" charset="-120"/>
+              </a:rPr>
+              <a:t>self-thinning is the primary control</a:t>
+            </a:r>
+            <a:endParaRPr lang="en-US" sz="1800" dirty="0"/>
+          </a:p>
+        </p:txBody>
+      </p:sp>
+      <p:sp>
+        <p:nvSpPr>
+          <p:cNvPr id="6" name="Text 4"/>
+          <p:cNvSpPr/>
+          <p:nvPr/>
+        </p:nvSpPr>
+        <p:spPr>
+          <a:xfrm>
+            <a:off x="822960" y="4617720"/>
+            <a:ext cx="10515600" cy="822960"/>
+          </a:xfrm>
+          <a:prstGeom prst="rect">
+            <a:avLst/>
+          </a:prstGeom>
+          <a:noFill/>
+          <a:ln/>
+        </p:spPr>
+        <p:txBody>
+          <a:bodyPr wrap="square" rtlCol="0" anchor="ctr"/>
+          <a:lstStyle/>
+          <a:p>
+            <a:pPr indent="0" marL="0">
+              <a:buNone/>
+            </a:pPr>
+            <a:r>
+              <a:rPr lang="en-US" sz="1600" i="1" dirty="0">
+                <a:solidFill>
+                  <a:srgbClr val="1A3D28"/>
+                </a:solidFill>
+                <a:latin typeface="Aptos" pitchFamily="34" charset="0"/>
+                <a:ea typeface="Aptos" pitchFamily="34" charset="-122"/>
+                <a:cs typeface="Aptos" pitchFamily="34" charset="-120"/>
+              </a:rPr>
+              <a:t>Same axis as the projection result: localizing the maximum pays off most where self-thinning governs stand dynamics</a:t>
+            </a:r>
+            <a:endParaRPr lang="en-US" sz="1600" dirty="0"/>
+          </a:p>
+        </p:txBody>
+      </p:sp>
+      <p:sp>
+        <p:nvSpPr>
+          <p:cNvPr id="7" name="Shape 5"/>
+          <p:cNvSpPr/>
+          <p:nvPr/>
+        </p:nvSpPr>
+        <p:spPr>
+          <a:xfrm>
+            <a:off x="0" y="6263640"/>
+            <a:ext cx="12188952" cy="594360"/>
+          </a:xfrm>
+          <a:prstGeom prst="rect">
             <a:avLst/>
           </a:prstGeom>
           <a:solidFill>
@@ -3291,399 +3443,7 @@
       </p:sp>
       <p:sp>
         <p:nvSpPr>
-          <p:cNvPr id="4" name="Text 2"/>
-          <p:cNvSpPr/>
-          <p:nvPr/>
-        </p:nvSpPr>
-        <p:spPr>
-          <a:xfrm>
-            <a:off x="640080" y="1600200"/>
-            <a:ext cx="502920" cy="502920"/>
-          </a:xfrm>
-          <a:prstGeom prst="rect">
-            <a:avLst/>
-          </a:prstGeom>
-          <a:noFill/>
-          <a:ln/>
-        </p:spPr>
-        <p:txBody>
-          <a:bodyPr wrap="square" rtlCol="0" anchor="ctr"/>
-          <a:lstStyle/>
-          <a:p>
-            <a:pPr algn="ctr" indent="0" marL="0">
-              <a:buNone/>
-            </a:pPr>
-            <a:r>
-              <a:rPr lang="en-US" sz="2000" b="1" dirty="0">
-                <a:solidFill>
-                  <a:srgbClr val="FFFFFF"/>
-                </a:solidFill>
-                <a:latin typeface="Aptos Display" pitchFamily="34" charset="0"/>
-                <a:ea typeface="Aptos Display" pitchFamily="34" charset="-122"/>
-                <a:cs typeface="Aptos Display" pitchFamily="34" charset="-120"/>
-              </a:rPr>
-              <a:t>1</a:t>
-            </a:r>
-            <a:endParaRPr lang="en-US" sz="2000" dirty="0"/>
-          </a:p>
-        </p:txBody>
-      </p:sp>
-      <p:sp>
-        <p:nvSpPr>
-          <p:cNvPr id="5" name="Text 3"/>
-          <p:cNvSpPr/>
-          <p:nvPr/>
-        </p:nvSpPr>
-        <p:spPr>
-          <a:xfrm>
-            <a:off x="1371600" y="1554480"/>
-            <a:ext cx="10058400" cy="868680"/>
-          </a:xfrm>
-          <a:prstGeom prst="rect">
-            <a:avLst/>
-          </a:prstGeom>
-          <a:noFill/>
-          <a:ln/>
-        </p:spPr>
-        <p:txBody>
-          <a:bodyPr wrap="square" rtlCol="0" anchor="ctr"/>
-          <a:lstStyle/>
-          <a:p>
-            <a:pPr indent="0" marL="0">
-              <a:buNone/>
-            </a:pPr>
-            <a:r>
-              <a:rPr lang="en-US" sz="1700" dirty="0">
-                <a:solidFill>
-                  <a:srgbClr val="333333"/>
-                </a:solidFill>
-                <a:latin typeface="Aptos" pitchFamily="34" charset="0"/>
-                <a:ea typeface="Aptos" pitchFamily="34" charset="-122"/>
-                <a:cs typeface="Aptos" pitchFamily="34" charset="-120"/>
-              </a:rPr>
-              <a:t>Treat maximum SDI as a localized, data-derived stand attribute from the FIA surface, not a species-weighted constant</a:t>
-            </a:r>
-            <a:endParaRPr lang="en-US" sz="1700" dirty="0"/>
-          </a:p>
-        </p:txBody>
-      </p:sp>
-      <p:sp>
-        <p:nvSpPr>
-          <p:cNvPr id="6" name="Shape 4"/>
-          <p:cNvSpPr/>
-          <p:nvPr/>
-        </p:nvSpPr>
-        <p:spPr>
-          <a:xfrm>
-            <a:off x="640080" y="2679192"/>
-            <a:ext cx="502920" cy="502920"/>
-          </a:xfrm>
-          <a:prstGeom prst="ellipse">
-            <a:avLst/>
-          </a:prstGeom>
-          <a:solidFill>
-            <a:srgbClr val="1A3D28"/>
-          </a:solidFill>
-          <a:ln/>
-        </p:spPr>
-      </p:sp>
-      <p:sp>
-        <p:nvSpPr>
-          <p:cNvPr id="7" name="Text 5"/>
-          <p:cNvSpPr/>
-          <p:nvPr/>
-        </p:nvSpPr>
-        <p:spPr>
-          <a:xfrm>
-            <a:off x="640080" y="2679192"/>
-            <a:ext cx="502920" cy="502920"/>
-          </a:xfrm>
-          <a:prstGeom prst="rect">
-            <a:avLst/>
-          </a:prstGeom>
-          <a:noFill/>
-          <a:ln/>
-        </p:spPr>
-        <p:txBody>
-          <a:bodyPr wrap="square" rtlCol="0" anchor="ctr"/>
-          <a:lstStyle/>
-          <a:p>
-            <a:pPr algn="ctr" indent="0" marL="0">
-              <a:buNone/>
-            </a:pPr>
-            <a:r>
-              <a:rPr lang="en-US" sz="2000" b="1" dirty="0">
-                <a:solidFill>
-                  <a:srgbClr val="FFFFFF"/>
-                </a:solidFill>
-                <a:latin typeface="Aptos Display" pitchFamily="34" charset="0"/>
-                <a:ea typeface="Aptos Display" pitchFamily="34" charset="-122"/>
-                <a:cs typeface="Aptos Display" pitchFamily="34" charset="-120"/>
-              </a:rPr>
-              <a:t>2</a:t>
-            </a:r>
-            <a:endParaRPr lang="en-US" sz="2000" dirty="0"/>
-          </a:p>
-        </p:txBody>
-      </p:sp>
-      <p:sp>
-        <p:nvSpPr>
           <p:cNvPr id="8" name="Text 6"/>
-          <p:cNvSpPr/>
-          <p:nvPr/>
-        </p:nvSpPr>
-        <p:spPr>
-          <a:xfrm>
-            <a:off x="1371600" y="2633472"/>
-            <a:ext cx="10058400" cy="868680"/>
-          </a:xfrm>
-          <a:prstGeom prst="rect">
-            <a:avLst/>
-          </a:prstGeom>
-          <a:noFill/>
-          <a:ln/>
-        </p:spPr>
-        <p:txBody>
-          <a:bodyPr wrap="square" rtlCol="0" anchor="ctr"/>
-          <a:lstStyle/>
-          <a:p>
-            <a:pPr indent="0" marL="0">
-              <a:buNone/>
-            </a:pPr>
-            <a:r>
-              <a:rPr lang="en-US" sz="1700" dirty="0">
-                <a:solidFill>
-                  <a:srgbClr val="333333"/>
-                </a:solidFill>
-                <a:latin typeface="Aptos" pitchFamily="34" charset="0"/>
-                <a:ea typeface="Aptos" pitchFamily="34" charset="-122"/>
-                <a:cs typeface="Aptos" pitchFamily="34" charset="-120"/>
-              </a:rPr>
-              <a:t>Adopt the spatial pattern and calibrate its level jointly with the density-dependent mortality response</a:t>
-            </a:r>
-            <a:endParaRPr lang="en-US" sz="1700" dirty="0"/>
-          </a:p>
-        </p:txBody>
-      </p:sp>
-      <p:sp>
-        <p:nvSpPr>
-          <p:cNvPr id="9" name="Shape 7"/>
-          <p:cNvSpPr/>
-          <p:nvPr/>
-        </p:nvSpPr>
-        <p:spPr>
-          <a:xfrm>
-            <a:off x="640080" y="3758184"/>
-            <a:ext cx="502920" cy="502920"/>
-          </a:xfrm>
-          <a:prstGeom prst="ellipse">
-            <a:avLst/>
-          </a:prstGeom>
-          <a:solidFill>
-            <a:srgbClr val="1A3D28"/>
-          </a:solidFill>
-          <a:ln/>
-        </p:spPr>
-      </p:sp>
-      <p:sp>
-        <p:nvSpPr>
-          <p:cNvPr id="10" name="Text 8"/>
-          <p:cNvSpPr/>
-          <p:nvPr/>
-        </p:nvSpPr>
-        <p:spPr>
-          <a:xfrm>
-            <a:off x="640080" y="3758184"/>
-            <a:ext cx="502920" cy="502920"/>
-          </a:xfrm>
-          <a:prstGeom prst="rect">
-            <a:avLst/>
-          </a:prstGeom>
-          <a:noFill/>
-          <a:ln/>
-        </p:spPr>
-        <p:txBody>
-          <a:bodyPr wrap="square" rtlCol="0" anchor="ctr"/>
-          <a:lstStyle/>
-          <a:p>
-            <a:pPr algn="ctr" indent="0" marL="0">
-              <a:buNone/>
-            </a:pPr>
-            <a:r>
-              <a:rPr lang="en-US" sz="2000" b="1" dirty="0">
-                <a:solidFill>
-                  <a:srgbClr val="FFFFFF"/>
-                </a:solidFill>
-                <a:latin typeface="Aptos Display" pitchFamily="34" charset="0"/>
-                <a:ea typeface="Aptos Display" pitchFamily="34" charset="-122"/>
-                <a:cs typeface="Aptos Display" pitchFamily="34" charset="-120"/>
-              </a:rPr>
-              <a:t>3</a:t>
-            </a:r>
-            <a:endParaRPr lang="en-US" sz="2000" dirty="0"/>
-          </a:p>
-        </p:txBody>
-      </p:sp>
-      <p:sp>
-        <p:nvSpPr>
-          <p:cNvPr id="11" name="Text 9"/>
-          <p:cNvSpPr/>
-          <p:nvPr/>
-        </p:nvSpPr>
-        <p:spPr>
-          <a:xfrm>
-            <a:off x="1371600" y="3712464"/>
-            <a:ext cx="10058400" cy="868680"/>
-          </a:xfrm>
-          <a:prstGeom prst="rect">
-            <a:avLst/>
-          </a:prstGeom>
-          <a:noFill/>
-          <a:ln/>
-        </p:spPr>
-        <p:txBody>
-          <a:bodyPr wrap="square" rtlCol="0" anchor="ctr"/>
-          <a:lstStyle/>
-          <a:p>
-            <a:pPr indent="0" marL="0">
-              <a:buNone/>
-            </a:pPr>
-            <a:r>
-              <a:rPr lang="en-US" sz="1700" dirty="0">
-                <a:solidFill>
-                  <a:srgbClr val="333333"/>
-                </a:solidFill>
-                <a:latin typeface="Aptos" pitchFamily="34" charset="0"/>
-                <a:ea typeface="Aptos" pitchFamily="34" charset="-122"/>
-                <a:cs typeface="Aptos" pitchFamily="34" charset="-120"/>
-              </a:rPr>
-              <a:t>Do not ship it as a drop-in SDIMAX override on a native variant without per-region revalidation</a:t>
-            </a:r>
-            <a:endParaRPr lang="en-US" sz="1700" dirty="0"/>
-          </a:p>
-        </p:txBody>
-      </p:sp>
-      <p:sp>
-        <p:nvSpPr>
-          <p:cNvPr id="12" name="Shape 10"/>
-          <p:cNvSpPr/>
-          <p:nvPr/>
-        </p:nvSpPr>
-        <p:spPr>
-          <a:xfrm>
-            <a:off x="640080" y="4837176"/>
-            <a:ext cx="502920" cy="502920"/>
-          </a:xfrm>
-          <a:prstGeom prst="ellipse">
-            <a:avLst/>
-          </a:prstGeom>
-          <a:solidFill>
-            <a:srgbClr val="1A3D28"/>
-          </a:solidFill>
-          <a:ln/>
-        </p:spPr>
-      </p:sp>
-      <p:sp>
-        <p:nvSpPr>
-          <p:cNvPr id="13" name="Text 11"/>
-          <p:cNvSpPr/>
-          <p:nvPr/>
-        </p:nvSpPr>
-        <p:spPr>
-          <a:xfrm>
-            <a:off x="640080" y="4837176"/>
-            <a:ext cx="502920" cy="502920"/>
-          </a:xfrm>
-          <a:prstGeom prst="rect">
-            <a:avLst/>
-          </a:prstGeom>
-          <a:noFill/>
-          <a:ln/>
-        </p:spPr>
-        <p:txBody>
-          <a:bodyPr wrap="square" rtlCol="0" anchor="ctr"/>
-          <a:lstStyle/>
-          <a:p>
-            <a:pPr algn="ctr" indent="0" marL="0">
-              <a:buNone/>
-            </a:pPr>
-            <a:r>
-              <a:rPr lang="en-US" sz="2000" b="1" dirty="0">
-                <a:solidFill>
-                  <a:srgbClr val="FFFFFF"/>
-                </a:solidFill>
-                <a:latin typeface="Aptos Display" pitchFamily="34" charset="0"/>
-                <a:ea typeface="Aptos Display" pitchFamily="34" charset="-122"/>
-                <a:cs typeface="Aptos Display" pitchFamily="34" charset="-120"/>
-              </a:rPr>
-              <a:t>4</a:t>
-            </a:r>
-            <a:endParaRPr lang="en-US" sz="2000" dirty="0"/>
-          </a:p>
-        </p:txBody>
-      </p:sp>
-      <p:sp>
-        <p:nvSpPr>
-          <p:cNvPr id="14" name="Text 12"/>
-          <p:cNvSpPr/>
-          <p:nvPr/>
-        </p:nvSpPr>
-        <p:spPr>
-          <a:xfrm>
-            <a:off x="1371600" y="4791456"/>
-            <a:ext cx="10058400" cy="868680"/>
-          </a:xfrm>
-          <a:prstGeom prst="rect">
-            <a:avLst/>
-          </a:prstGeom>
-          <a:noFill/>
-          <a:ln/>
-        </p:spPr>
-        <p:txBody>
-          <a:bodyPr wrap="square" rtlCol="0" anchor="ctr"/>
-          <a:lstStyle/>
-          <a:p>
-            <a:pPr indent="0" marL="0">
-              <a:buNone/>
-            </a:pPr>
-            <a:r>
-              <a:rPr lang="en-US" sz="1700" dirty="0">
-                <a:solidFill>
-                  <a:srgbClr val="333333"/>
-                </a:solidFill>
-                <a:latin typeface="Aptos" pitchFamily="34" charset="0"/>
-                <a:ea typeface="Aptos" pitchFamily="34" charset="-122"/>
-                <a:cs typeface="Aptos" pitchFamily="34" charset="-120"/>
-              </a:rPr>
-              <a:t>Guidance welcome on benchmark design, the engine integration path, and the SDI convention to match</a:t>
-            </a:r>
-            <a:endParaRPr lang="en-US" sz="1700" dirty="0"/>
-          </a:p>
-        </p:txBody>
-      </p:sp>
-      <p:sp>
-        <p:nvSpPr>
-          <p:cNvPr id="15" name="Shape 13"/>
-          <p:cNvSpPr/>
-          <p:nvPr/>
-        </p:nvSpPr>
-        <p:spPr>
-          <a:xfrm>
-            <a:off x="0" y="6263640"/>
-            <a:ext cx="12188952" cy="594360"/>
-          </a:xfrm>
-          <a:prstGeom prst="rect">
-            <a:avLst/>
-          </a:prstGeom>
-          <a:solidFill>
-            <a:srgbClr val="1A3D28"/>
-          </a:solidFill>
-          <a:ln/>
-        </p:spPr>
-      </p:sp>
-      <p:sp>
-        <p:nvSpPr>
-          <p:cNvPr id="16" name="Text 14"/>
           <p:cNvSpPr/>
           <p:nvPr/>
         </p:nvSpPr>
@@ -3714,7 +3474,7 @@
                 <a:ea typeface="Aptos" pitchFamily="34" charset="-122"/>
                 <a:cs typeface="Aptos" pitchFamily="34" charset="-120"/>
               </a:rPr>
-              <a:t>Localize the maximum, calibrate the level, and validate by region</a:t>
+              <a:t>Get the maximum right first in the East, South, and moist West</a:t>
             </a:r>
             <a:endParaRPr lang="en-US" sz="1800" dirty="0"/>
           </a:p>
@@ -3731,6 +3491,528 @@
 <file path=ppt/slides/slide14.xml><?xml version="1.0" encoding="utf-8"?>
 <p:sld xmlns:a="http://schemas.openxmlformats.org/drawingml/2006/main" xmlns:r="http://schemas.openxmlformats.org/officeDocument/2006/relationships" xmlns:p="http://schemas.openxmlformats.org/presentationml/2006/main">
   <p:cSld name="Slide 14">
+    <p:bg>
+      <p:bgPr>
+        <a:solidFill>
+          <a:srgbClr val="FFFFFF"/>
+        </a:solidFill>
+      </p:bgPr>
+    </p:bg>
+    <p:spTree>
+      <p:nvGrpSpPr>
+        <p:cNvPr id="1" name=""/>
+        <p:cNvGrpSpPr/>
+        <p:nvPr/>
+      </p:nvGrpSpPr>
+      <p:grpSpPr>
+        <a:xfrm>
+          <a:off x="0" y="0"/>
+          <a:ext cx="0" cy="0"/>
+          <a:chOff x="0" y="0"/>
+          <a:chExt cx="0" cy="0"/>
+        </a:xfrm>
+      </p:grpSpPr>
+      <p:sp>
+        <p:nvSpPr>
+          <p:cNvPr id="2" name="Text 0"/>
+          <p:cNvSpPr/>
+          <p:nvPr/>
+        </p:nvSpPr>
+        <p:spPr>
+          <a:xfrm>
+            <a:off x="548640" y="320040"/>
+            <a:ext cx="11064240" cy="822960"/>
+          </a:xfrm>
+          <a:prstGeom prst="rect">
+            <a:avLst/>
+          </a:prstGeom>
+          <a:noFill/>
+          <a:ln/>
+        </p:spPr>
+        <p:txBody>
+          <a:bodyPr wrap="square" rtlCol="0" anchor="ctr"/>
+          <a:lstStyle/>
+          <a:p>
+            <a:pPr algn="l" indent="0" marL="0">
+              <a:buNone/>
+            </a:pPr>
+            <a:r>
+              <a:rPr lang="en-US" sz="3000" dirty="0">
+                <a:solidFill>
+                  <a:srgbClr val="333333"/>
+                </a:solidFill>
+                <a:latin typeface="Aptos Display" pitchFamily="34" charset="0"/>
+                <a:ea typeface="Aptos Display" pitchFamily="34" charset="-122"/>
+                <a:cs typeface="Aptos Display" pitchFamily="34" charset="-120"/>
+              </a:rPr>
+              <a:t>Recommendations for the FVS team</a:t>
+            </a:r>
+            <a:endParaRPr lang="en-US" sz="3000" dirty="0"/>
+          </a:p>
+        </p:txBody>
+      </p:sp>
+      <p:sp>
+        <p:nvSpPr>
+          <p:cNvPr id="3" name="Shape 1"/>
+          <p:cNvSpPr/>
+          <p:nvPr/>
+        </p:nvSpPr>
+        <p:spPr>
+          <a:xfrm>
+            <a:off x="640080" y="1600200"/>
+            <a:ext cx="502920" cy="502920"/>
+          </a:xfrm>
+          <a:prstGeom prst="ellipse">
+            <a:avLst/>
+          </a:prstGeom>
+          <a:solidFill>
+            <a:srgbClr val="1A3D28"/>
+          </a:solidFill>
+          <a:ln/>
+        </p:spPr>
+      </p:sp>
+      <p:sp>
+        <p:nvSpPr>
+          <p:cNvPr id="4" name="Text 2"/>
+          <p:cNvSpPr/>
+          <p:nvPr/>
+        </p:nvSpPr>
+        <p:spPr>
+          <a:xfrm>
+            <a:off x="640080" y="1600200"/>
+            <a:ext cx="502920" cy="502920"/>
+          </a:xfrm>
+          <a:prstGeom prst="rect">
+            <a:avLst/>
+          </a:prstGeom>
+          <a:noFill/>
+          <a:ln/>
+        </p:spPr>
+        <p:txBody>
+          <a:bodyPr wrap="square" rtlCol="0" anchor="ctr"/>
+          <a:lstStyle/>
+          <a:p>
+            <a:pPr algn="ctr" indent="0" marL="0">
+              <a:buNone/>
+            </a:pPr>
+            <a:r>
+              <a:rPr lang="en-US" sz="2000" b="1" dirty="0">
+                <a:solidFill>
+                  <a:srgbClr val="FFFFFF"/>
+                </a:solidFill>
+                <a:latin typeface="Aptos Display" pitchFamily="34" charset="0"/>
+                <a:ea typeface="Aptos Display" pitchFamily="34" charset="-122"/>
+                <a:cs typeface="Aptos Display" pitchFamily="34" charset="-120"/>
+              </a:rPr>
+              <a:t>1</a:t>
+            </a:r>
+            <a:endParaRPr lang="en-US" sz="2000" dirty="0"/>
+          </a:p>
+        </p:txBody>
+      </p:sp>
+      <p:sp>
+        <p:nvSpPr>
+          <p:cNvPr id="5" name="Text 3"/>
+          <p:cNvSpPr/>
+          <p:nvPr/>
+        </p:nvSpPr>
+        <p:spPr>
+          <a:xfrm>
+            <a:off x="1371600" y="1554480"/>
+            <a:ext cx="10058400" cy="868680"/>
+          </a:xfrm>
+          <a:prstGeom prst="rect">
+            <a:avLst/>
+          </a:prstGeom>
+          <a:noFill/>
+          <a:ln/>
+        </p:spPr>
+        <p:txBody>
+          <a:bodyPr wrap="square" rtlCol="0" anchor="ctr"/>
+          <a:lstStyle/>
+          <a:p>
+            <a:pPr indent="0" marL="0">
+              <a:buNone/>
+            </a:pPr>
+            <a:r>
+              <a:rPr lang="en-US" sz="1700" dirty="0">
+                <a:solidFill>
+                  <a:srgbClr val="333333"/>
+                </a:solidFill>
+                <a:latin typeface="Aptos" pitchFamily="34" charset="0"/>
+                <a:ea typeface="Aptos" pitchFamily="34" charset="-122"/>
+                <a:cs typeface="Aptos" pitchFamily="34" charset="-120"/>
+              </a:rPr>
+              <a:t>Treat maximum SDI as a localized, data-derived stand attribute from the FIA surface, not a species-weighted constant</a:t>
+            </a:r>
+            <a:endParaRPr lang="en-US" sz="1700" dirty="0"/>
+          </a:p>
+        </p:txBody>
+      </p:sp>
+      <p:sp>
+        <p:nvSpPr>
+          <p:cNvPr id="6" name="Shape 4"/>
+          <p:cNvSpPr/>
+          <p:nvPr/>
+        </p:nvSpPr>
+        <p:spPr>
+          <a:xfrm>
+            <a:off x="640080" y="2679192"/>
+            <a:ext cx="502920" cy="502920"/>
+          </a:xfrm>
+          <a:prstGeom prst="ellipse">
+            <a:avLst/>
+          </a:prstGeom>
+          <a:solidFill>
+            <a:srgbClr val="1A3D28"/>
+          </a:solidFill>
+          <a:ln/>
+        </p:spPr>
+      </p:sp>
+      <p:sp>
+        <p:nvSpPr>
+          <p:cNvPr id="7" name="Text 5"/>
+          <p:cNvSpPr/>
+          <p:nvPr/>
+        </p:nvSpPr>
+        <p:spPr>
+          <a:xfrm>
+            <a:off x="640080" y="2679192"/>
+            <a:ext cx="502920" cy="502920"/>
+          </a:xfrm>
+          <a:prstGeom prst="rect">
+            <a:avLst/>
+          </a:prstGeom>
+          <a:noFill/>
+          <a:ln/>
+        </p:spPr>
+        <p:txBody>
+          <a:bodyPr wrap="square" rtlCol="0" anchor="ctr"/>
+          <a:lstStyle/>
+          <a:p>
+            <a:pPr algn="ctr" indent="0" marL="0">
+              <a:buNone/>
+            </a:pPr>
+            <a:r>
+              <a:rPr lang="en-US" sz="2000" b="1" dirty="0">
+                <a:solidFill>
+                  <a:srgbClr val="FFFFFF"/>
+                </a:solidFill>
+                <a:latin typeface="Aptos Display" pitchFamily="34" charset="0"/>
+                <a:ea typeface="Aptos Display" pitchFamily="34" charset="-122"/>
+                <a:cs typeface="Aptos Display" pitchFamily="34" charset="-120"/>
+              </a:rPr>
+              <a:t>2</a:t>
+            </a:r>
+            <a:endParaRPr lang="en-US" sz="2000" dirty="0"/>
+          </a:p>
+        </p:txBody>
+      </p:sp>
+      <p:sp>
+        <p:nvSpPr>
+          <p:cNvPr id="8" name="Text 6"/>
+          <p:cNvSpPr/>
+          <p:nvPr/>
+        </p:nvSpPr>
+        <p:spPr>
+          <a:xfrm>
+            <a:off x="1371600" y="2633472"/>
+            <a:ext cx="10058400" cy="868680"/>
+          </a:xfrm>
+          <a:prstGeom prst="rect">
+            <a:avLst/>
+          </a:prstGeom>
+          <a:noFill/>
+          <a:ln/>
+        </p:spPr>
+        <p:txBody>
+          <a:bodyPr wrap="square" rtlCol="0" anchor="ctr"/>
+          <a:lstStyle/>
+          <a:p>
+            <a:pPr indent="0" marL="0">
+              <a:buNone/>
+            </a:pPr>
+            <a:r>
+              <a:rPr lang="en-US" sz="1700" dirty="0">
+                <a:solidFill>
+                  <a:srgbClr val="333333"/>
+                </a:solidFill>
+                <a:latin typeface="Aptos" pitchFamily="34" charset="0"/>
+                <a:ea typeface="Aptos" pitchFamily="34" charset="-122"/>
+                <a:cs typeface="Aptos" pitchFamily="34" charset="-120"/>
+              </a:rPr>
+              <a:t>Adopt the spatial pattern and calibrate its level jointly with the density-dependent mortality response</a:t>
+            </a:r>
+            <a:endParaRPr lang="en-US" sz="1700" dirty="0"/>
+          </a:p>
+        </p:txBody>
+      </p:sp>
+      <p:sp>
+        <p:nvSpPr>
+          <p:cNvPr id="9" name="Shape 7"/>
+          <p:cNvSpPr/>
+          <p:nvPr/>
+        </p:nvSpPr>
+        <p:spPr>
+          <a:xfrm>
+            <a:off x="640080" y="3758184"/>
+            <a:ext cx="502920" cy="502920"/>
+          </a:xfrm>
+          <a:prstGeom prst="ellipse">
+            <a:avLst/>
+          </a:prstGeom>
+          <a:solidFill>
+            <a:srgbClr val="1A3D28"/>
+          </a:solidFill>
+          <a:ln/>
+        </p:spPr>
+      </p:sp>
+      <p:sp>
+        <p:nvSpPr>
+          <p:cNvPr id="10" name="Text 8"/>
+          <p:cNvSpPr/>
+          <p:nvPr/>
+        </p:nvSpPr>
+        <p:spPr>
+          <a:xfrm>
+            <a:off x="640080" y="3758184"/>
+            <a:ext cx="502920" cy="502920"/>
+          </a:xfrm>
+          <a:prstGeom prst="rect">
+            <a:avLst/>
+          </a:prstGeom>
+          <a:noFill/>
+          <a:ln/>
+        </p:spPr>
+        <p:txBody>
+          <a:bodyPr wrap="square" rtlCol="0" anchor="ctr"/>
+          <a:lstStyle/>
+          <a:p>
+            <a:pPr algn="ctr" indent="0" marL="0">
+              <a:buNone/>
+            </a:pPr>
+            <a:r>
+              <a:rPr lang="en-US" sz="2000" b="1" dirty="0">
+                <a:solidFill>
+                  <a:srgbClr val="FFFFFF"/>
+                </a:solidFill>
+                <a:latin typeface="Aptos Display" pitchFamily="34" charset="0"/>
+                <a:ea typeface="Aptos Display" pitchFamily="34" charset="-122"/>
+                <a:cs typeface="Aptos Display" pitchFamily="34" charset="-120"/>
+              </a:rPr>
+              <a:t>3</a:t>
+            </a:r>
+            <a:endParaRPr lang="en-US" sz="2000" dirty="0"/>
+          </a:p>
+        </p:txBody>
+      </p:sp>
+      <p:sp>
+        <p:nvSpPr>
+          <p:cNvPr id="11" name="Text 9"/>
+          <p:cNvSpPr/>
+          <p:nvPr/>
+        </p:nvSpPr>
+        <p:spPr>
+          <a:xfrm>
+            <a:off x="1371600" y="3712464"/>
+            <a:ext cx="10058400" cy="868680"/>
+          </a:xfrm>
+          <a:prstGeom prst="rect">
+            <a:avLst/>
+          </a:prstGeom>
+          <a:noFill/>
+          <a:ln/>
+        </p:spPr>
+        <p:txBody>
+          <a:bodyPr wrap="square" rtlCol="0" anchor="ctr"/>
+          <a:lstStyle/>
+          <a:p>
+            <a:pPr indent="0" marL="0">
+              <a:buNone/>
+            </a:pPr>
+            <a:r>
+              <a:rPr lang="en-US" sz="1700" dirty="0">
+                <a:solidFill>
+                  <a:srgbClr val="333333"/>
+                </a:solidFill>
+                <a:latin typeface="Aptos" pitchFamily="34" charset="0"/>
+                <a:ea typeface="Aptos" pitchFamily="34" charset="-122"/>
+                <a:cs typeface="Aptos" pitchFamily="34" charset="-120"/>
+              </a:rPr>
+              <a:t>Do not ship it as a drop-in SDIMAX override on a native variant without per-region revalidation</a:t>
+            </a:r>
+            <a:endParaRPr lang="en-US" sz="1700" dirty="0"/>
+          </a:p>
+        </p:txBody>
+      </p:sp>
+      <p:sp>
+        <p:nvSpPr>
+          <p:cNvPr id="12" name="Shape 10"/>
+          <p:cNvSpPr/>
+          <p:nvPr/>
+        </p:nvSpPr>
+        <p:spPr>
+          <a:xfrm>
+            <a:off x="640080" y="4837176"/>
+            <a:ext cx="502920" cy="502920"/>
+          </a:xfrm>
+          <a:prstGeom prst="ellipse">
+            <a:avLst/>
+          </a:prstGeom>
+          <a:solidFill>
+            <a:srgbClr val="1A3D28"/>
+          </a:solidFill>
+          <a:ln/>
+        </p:spPr>
+      </p:sp>
+      <p:sp>
+        <p:nvSpPr>
+          <p:cNvPr id="13" name="Text 11"/>
+          <p:cNvSpPr/>
+          <p:nvPr/>
+        </p:nvSpPr>
+        <p:spPr>
+          <a:xfrm>
+            <a:off x="640080" y="4837176"/>
+            <a:ext cx="502920" cy="502920"/>
+          </a:xfrm>
+          <a:prstGeom prst="rect">
+            <a:avLst/>
+          </a:prstGeom>
+          <a:noFill/>
+          <a:ln/>
+        </p:spPr>
+        <p:txBody>
+          <a:bodyPr wrap="square" rtlCol="0" anchor="ctr"/>
+          <a:lstStyle/>
+          <a:p>
+            <a:pPr algn="ctr" indent="0" marL="0">
+              <a:buNone/>
+            </a:pPr>
+            <a:r>
+              <a:rPr lang="en-US" sz="2000" b="1" dirty="0">
+                <a:solidFill>
+                  <a:srgbClr val="FFFFFF"/>
+                </a:solidFill>
+                <a:latin typeface="Aptos Display" pitchFamily="34" charset="0"/>
+                <a:ea typeface="Aptos Display" pitchFamily="34" charset="-122"/>
+                <a:cs typeface="Aptos Display" pitchFamily="34" charset="-120"/>
+              </a:rPr>
+              <a:t>4</a:t>
+            </a:r>
+            <a:endParaRPr lang="en-US" sz="2000" dirty="0"/>
+          </a:p>
+        </p:txBody>
+      </p:sp>
+      <p:sp>
+        <p:nvSpPr>
+          <p:cNvPr id="14" name="Text 12"/>
+          <p:cNvSpPr/>
+          <p:nvPr/>
+        </p:nvSpPr>
+        <p:spPr>
+          <a:xfrm>
+            <a:off x="1371600" y="4791456"/>
+            <a:ext cx="10058400" cy="868680"/>
+          </a:xfrm>
+          <a:prstGeom prst="rect">
+            <a:avLst/>
+          </a:prstGeom>
+          <a:noFill/>
+          <a:ln/>
+        </p:spPr>
+        <p:txBody>
+          <a:bodyPr wrap="square" rtlCol="0" anchor="ctr"/>
+          <a:lstStyle/>
+          <a:p>
+            <a:pPr indent="0" marL="0">
+              <a:buNone/>
+            </a:pPr>
+            <a:r>
+              <a:rPr lang="en-US" sz="1700" dirty="0">
+                <a:solidFill>
+                  <a:srgbClr val="333333"/>
+                </a:solidFill>
+                <a:latin typeface="Aptos" pitchFamily="34" charset="0"/>
+                <a:ea typeface="Aptos" pitchFamily="34" charset="-122"/>
+                <a:cs typeface="Aptos" pitchFamily="34" charset="-120"/>
+              </a:rPr>
+              <a:t>Guidance welcome on benchmark design, the engine integration path, and the SDI convention to match</a:t>
+            </a:r>
+            <a:endParaRPr lang="en-US" sz="1700" dirty="0"/>
+          </a:p>
+        </p:txBody>
+      </p:sp>
+      <p:sp>
+        <p:nvSpPr>
+          <p:cNvPr id="15" name="Shape 13"/>
+          <p:cNvSpPr/>
+          <p:nvPr/>
+        </p:nvSpPr>
+        <p:spPr>
+          <a:xfrm>
+            <a:off x="0" y="6263640"/>
+            <a:ext cx="12188952" cy="594360"/>
+          </a:xfrm>
+          <a:prstGeom prst="rect">
+            <a:avLst/>
+          </a:prstGeom>
+          <a:solidFill>
+            <a:srgbClr val="1A3D28"/>
+          </a:solidFill>
+          <a:ln/>
+        </p:spPr>
+      </p:sp>
+      <p:sp>
+        <p:nvSpPr>
+          <p:cNvPr id="16" name="Text 14"/>
+          <p:cNvSpPr/>
+          <p:nvPr/>
+        </p:nvSpPr>
+        <p:spPr>
+          <a:xfrm>
+            <a:off x="457200" y="6263640"/>
+            <a:ext cx="11247120" cy="594360"/>
+          </a:xfrm>
+          <a:prstGeom prst="rect">
+            <a:avLst/>
+          </a:prstGeom>
+          <a:noFill/>
+          <a:ln/>
+        </p:spPr>
+        <p:txBody>
+          <a:bodyPr wrap="square" rtlCol="0" anchor="ctr"/>
+          <a:lstStyle/>
+          <a:p>
+            <a:pPr algn="l" indent="0" marL="0">
+              <a:buNone/>
+            </a:pPr>
+            <a:r>
+              <a:rPr lang="en-US" sz="1800" dirty="0">
+                <a:solidFill>
+                  <a:srgbClr val="FFFFFF"/>
+                </a:solidFill>
+                <a:latin typeface="Aptos" pitchFamily="34" charset="0"/>
+                <a:ea typeface="Aptos" pitchFamily="34" charset="-122"/>
+                <a:cs typeface="Aptos" pitchFamily="34" charset="-120"/>
+              </a:rPr>
+              <a:t>Localize the maximum, calibrate the level, and validate by region</a:t>
+            </a:r>
+            <a:endParaRPr lang="en-US" sz="1800" dirty="0"/>
+          </a:p>
+        </p:txBody>
+      </p:sp>
+    </p:spTree>
+  </p:cSld>
+  <p:clrMapOvr>
+    <a:masterClrMapping/>
+  </p:clrMapOvr>
+</p:sld>
+</file>
+
+<file path=ppt/slides/slide15.xml><?xml version="1.0" encoding="utf-8"?>
+<p:sld xmlns:a="http://schemas.openxmlformats.org/drawingml/2006/main" xmlns:r="http://schemas.openxmlformats.org/officeDocument/2006/relationships" xmlns:p="http://schemas.openxmlformats.org/presentationml/2006/main">
+  <p:cSld name="Slide 15">
     <p:bg>
       <p:bgPr>
         <a:solidFill>

</xml_diff>